<commit_message>
Update domain to novadao.net + add promo video with music
- Replace all novadao.xyz references with novadao.net
- Add cinematic background music to Remotion video
- Redesign Scene 2: centered layout with feature highlights
- Regenerate pitch deck with updated domain
- Add rendered NovaDAO_Promo.mp4

Co-Authored-By: Claude Opus 4.6 <noreply@anthropic.com>
</commit_message>
<xml_diff>
--- a/NovaDAO_Pitch_Deck.pptx
+++ b/NovaDAO_Pitch_Deck.pptx
@@ -8082,7 +8082,7 @@
                 <a:ea typeface="Calibri" pitchFamily="34" charset="-122"/>
                 <a:cs typeface="Calibri" pitchFamily="34" charset="-120"/>
               </a:rPr>
-              <a:t>novadao.xyz</a:t>
+              <a:t>novadao.net</a:t>
             </a:r>
             <a:endParaRPr lang="en-US" sz="1200" dirty="0"/>
           </a:p>
@@ -8160,7 +8160,7 @@
                 <a:ea typeface="Calibri" pitchFamily="34" charset="-122"/>
                 <a:cs typeface="Calibri" pitchFamily="34" charset="-120"/>
               </a:rPr>
-              <a:t>@NovaDAO_xyz</a:t>
+              <a:t>@NovaDAO_net</a:t>
             </a:r>
             <a:endParaRPr lang="en-US" sz="1200" dirty="0"/>
           </a:p>
@@ -8316,7 +8316,7 @@
                 <a:ea typeface="Calibri" pitchFamily="34" charset="-122"/>
                 <a:cs typeface="Calibri" pitchFamily="34" charset="-120"/>
               </a:rPr>
-              <a:t>hello@novadao.xyz</a:t>
+              <a:t>hello@novadao.net</a:t>
             </a:r>
             <a:endParaRPr lang="en-US" sz="1200" dirty="0"/>
           </a:p>

</xml_diff>